<commit_message>
Portada de la presentación con la ilustración del kit en rayos X
Co-Authored-By: Claude Opus 5.5 <noreply@anthropic.com>
Claude-Session: https://claude.ai/code/session_01XFRiwZEaKzWSUtwMK7etUG
</commit_message>
<xml_diff>
--- a/control-de-gestion/Lumine_Analisis_Estrategico_Control_de_Gestion.pptx
+++ b/control-de-gestion/Lumine_Analisis_Estrategico_Control_de_Gestion.pptx
@@ -131,7 +131,7 @@
   <p:extLst>
     <p:ext uri="{521415D9-36F7-43E2-AB2F-B90AF26B5E84}">
       <p14:sectionLst xmlns:p14="http://schemas.microsoft.com/office/powerpoint/2010/main">
-        <p14:section name="1 · Diego Alarcón" id="{f8264448-de84-376a-b268-e19cd1cc9e34}">
+        <p14:section name="1 · Diego Alarcón" id="{aaddc338-5355-7ea7-fe3a-e5c3b7282644}">
           <p14:sldIdLst>
             <p14:sldId id="256"/>
             <p14:sldId id="257"/>
@@ -140,7 +140,7 @@
             <p14:sldId id="260"/>
           </p14:sldIdLst>
         </p14:section>
-        <p14:section name="2 · Benjamín Torres" id="{2d4beea6-a238-2e61-9d96-7a536d1ab05f}">
+        <p14:section name="2 · Benjamín Torres" id="{8e7f1b75-1ab3-775d-e8e2-6ce55cc41a65}">
           <p14:sldIdLst>
             <p14:sldId id="261"/>
             <p14:sldId id="262"/>
@@ -149,7 +149,7 @@
             <p14:sldId id="265"/>
           </p14:sldIdLst>
         </p14:section>
-        <p14:section name="3 · Lukas Verdugo" id="{30596469-88c5-369a-2bd8-1b644d172661}">
+        <p14:section name="3 · Lukas Verdugo" id="{3ffa71c1-54d0-3340-b0cf-71e831e2de4c}">
           <p14:sldIdLst>
             <p14:sldId id="266"/>
             <p14:sldId id="267"/>
@@ -159,7 +159,7 @@
             <p14:sldId id="271"/>
           </p14:sldIdLst>
         </p14:section>
-        <p14:section name="Anexo" id="{0b5f6152-9d58-1e02-5d35-01a52cf8512c}">
+        <p14:section name="Anexo" id="{7654d4d7-4f21-0fe3-bc30-601b46f18939}">
           <p14:sldIdLst>
             <p14:sldId id="272"/>
             <p14:sldId id="273"/>
@@ -3985,8 +3985,8 @@
         </p:nvSpPr>
         <p:spPr>
           <a:xfrm>
-            <a:off x="548640" y="1572768"/>
-            <a:ext cx="11094415" cy="1783080"/>
+            <a:off x="548640" y="1207008"/>
+            <a:ext cx="11094415" cy="914400"/>
           </a:xfrm>
           <a:prstGeom prst="rect">
             <a:avLst/>
@@ -4002,7 +4002,7 @@
                 <a:spcPct val="86000"/>
               </a:lnSpc>
               <a:buNone/>
-              <a:defRPr lang="en-US" sz="6000" dirty="0">
+              <a:defRPr lang="en-US" sz="5000" dirty="0">
                 <a:solidFill>
                   <a:schemeClr val="tx1"/>
                 </a:solidFill>
@@ -4019,7 +4019,7 @@
               </a:lnSpc>
               <a:buNone/>
             </a:pPr>
-            <a:endParaRPr lang="en-US" sz="6000" dirty="0"/>
+            <a:endParaRPr lang="en-US" sz="5000" dirty="0"/>
           </a:p>
         </p:txBody>
       </p:sp>
@@ -4783,151 +4783,9 @@
           <a:chExt cx="0" cy="0"/>
         </a:xfrm>
       </p:grpSpPr>
-      <p:sp>
-        <p:nvSpPr>
-          <p:cNvPr id="2" name="Text 0"/>
-          <p:cNvSpPr txBox="1"/>
-          <p:nvPr/>
-        </p:nvSpPr>
-        <p:spPr>
-          <a:xfrm>
-            <a:off x="6583680" y="365760"/>
-            <a:ext cx="5059375" cy="237744"/>
-          </a:xfrm>
-          <a:prstGeom prst="rect">
-            <a:avLst/>
-          </a:prstGeom>
-          <a:noFill/>
-          <a:ln/>
-        </p:spPr>
-        <p:txBody>
-          <a:bodyPr wrap="square" lIns="0" tIns="0" rIns="0" bIns="0" rtlCol="0" anchor="ctr"/>
-          <a:lstStyle/>
-          <a:p>
-            <a:pPr algn="r" indent="0" marL="0">
-              <a:buNone/>
-            </a:pPr>
-            <a:r>
-              <a:rPr lang="es-CL" altLang="en-US" sz="900" spc="150" kern="0" dirty="0">
-                <a:solidFill>
-                  <a:schemeClr val="tx2"/>
-                </a:solidFill>
-                <a:latin typeface="IBM Plex Mono" pitchFamily="34" charset="0"/>
-                <a:ea typeface="IBM Plex Mono" pitchFamily="34" charset="-122"/>
-                <a:cs typeface="IBM Plex Mono" pitchFamily="34" charset="-120"/>
-              </a:rPr>
-              <a:t>UNAB · OCTUBRE 2026</a:t>
-            </a:r>
-            <a:endParaRPr lang="es-CL" sz="900" dirty="0"/>
-          </a:p>
-        </p:txBody>
-      </p:sp>
-      <p:sp>
-        <p:nvSpPr>
-          <p:cNvPr id="3" name="Text 1"/>
-          <p:cNvSpPr txBox="1"/>
-          <p:nvPr/>
-        </p:nvSpPr>
-        <p:spPr>
-          <a:xfrm>
-            <a:off x="548640" y="1115568"/>
-            <a:ext cx="11094415" cy="274320"/>
-          </a:xfrm>
-          <a:prstGeom prst="rect">
-            <a:avLst/>
-          </a:prstGeom>
-          <a:noFill/>
-          <a:ln/>
-        </p:spPr>
-        <p:txBody>
-          <a:bodyPr wrap="square" lIns="0" tIns="0" rIns="0" bIns="0" rtlCol="0" anchor="ctr"/>
-          <a:lstStyle/>
-          <a:p>
-            <a:pPr algn="ctr" indent="0" marL="0">
-              <a:buNone/>
-            </a:pPr>
-            <a:r>
-              <a:rPr lang="es-CL" altLang="en-US" sz="1000" spc="150" kern="0" dirty="0">
-                <a:solidFill>
-                  <a:schemeClr val="tx2"/>
-                </a:solidFill>
-                <a:latin typeface="IBM Plex Mono" pitchFamily="34" charset="0"/>
-                <a:ea typeface="IBM Plex Mono" pitchFamily="34" charset="-122"/>
-                <a:cs typeface="IBM Plex Mono" pitchFamily="34" charset="-120"/>
-              </a:rPr>
-              <a:t>DESARROLLO DE LA ESTRATEGIA · LUMINE MOTORS CHILE SPA</a:t>
-            </a:r>
-            <a:endParaRPr lang="es-CL" sz="1000" dirty="0"/>
-          </a:p>
-        </p:txBody>
-      </p:sp>
-      <p:sp>
-        <p:nvSpPr>
-          <p:cNvPr id="4" name="Text 0"/>
-          <p:cNvSpPr/>
-          <p:nvPr>
-            <p:ph idx="101" type="title" hasCustomPrompt="1"/>
-          </p:nvPr>
-        </p:nvSpPr>
-        <p:spPr>
-          <a:xfrm>
-            <a:off x="548640" y="1572768"/>
-            <a:ext cx="11094415" cy="1783080"/>
-          </a:xfrm>
-          <a:prstGeom prst="rect">
-            <a:avLst/>
-          </a:prstGeom>
-          <a:noFill/>
-          <a:ln/>
-        </p:spPr>
-        <p:txBody>
-          <a:bodyPr wrap="square" lIns="0" tIns="0" rIns="0" bIns="0" rtlCol="0" anchor="t"/>
-          <a:lstStyle/>
-          <a:p>
-            <a:pPr algn="ctr" indent="0" marL="0">
-              <a:lnSpc>
-                <a:spcPct val="86000"/>
-              </a:lnSpc>
-              <a:buNone/>
-            </a:pPr>
-            <a:r>
-              <a:rPr lang="en-US" sz="6000" dirty="0">
-                <a:solidFill>
-                  <a:schemeClr val="tx1"/>
-                </a:solidFill>
-                <a:latin typeface="Archivo SemiExpanded ExtraBold" pitchFamily="34" charset="0"/>
-                <a:ea typeface="Archivo SemiExpanded ExtraBold" pitchFamily="34" charset="-122"/>
-                <a:cs typeface="Archivo SemiExpanded ExtraBold" pitchFamily="34" charset="-120"/>
-              </a:rPr>
-              <a:t>ANÁLISIS</a:t>
-            </a:r>
-            <a:endParaRPr lang="en-US" sz="6000" dirty="0"/>
-          </a:p>
-          <a:p>
-            <a:pPr algn="ctr" indent="0" marL="0">
-              <a:lnSpc>
-                <a:spcPct val="86000"/>
-              </a:lnSpc>
-              <a:buNone/>
-            </a:pPr>
-            <a:r>
-              <a:rPr lang="en-US" sz="7600" i="1" dirty="0">
-                <a:solidFill>
-                  <a:schemeClr val="accent1"/>
-                </a:solidFill>
-                <a:latin typeface="Instrument Serif" pitchFamily="34" charset="0"/>
-                <a:ea typeface="Instrument Serif" pitchFamily="34" charset="-122"/>
-                <a:cs typeface="Instrument Serif" pitchFamily="34" charset="-120"/>
-              </a:rPr>
-              <a:t>estratégico.</a:t>
-            </a:r>
-            <a:endParaRPr lang="en-US" sz="6000" dirty="0"/>
-          </a:p>
-        </p:txBody>
-      </p:sp>
       <p:pic>
         <p:nvPicPr>
-          <p:cNvPr id="5" name="Image 0" descr="Plano del kit Lumine: auto en vista lateral con el motor eléctrico en el eje trasero">    </p:cNvPr>
+          <p:cNvPr id="2" name="Image 0" descr="Ilustración conceptual: auto en rayos X con el kit Lumine (unidad de control, baterías bajo el piso y motor eléctrico en el eje trasero)">    </p:cNvPr>
           <p:cNvPicPr>
             <a:picLocks noChangeAspect="1"/>
           </p:cNvPicPr>
@@ -4941,17 +4799,226 @@
         </p:blipFill>
         <p:spPr>
           <a:xfrm>
-            <a:off x="2712568" y="3310128"/>
-            <a:ext cx="6766560" cy="2086356"/>
+            <a:off x="0" y="411480"/>
+            <a:ext cx="12191695" cy="6861474"/>
           </a:xfrm>
           <a:prstGeom prst="rect">
             <a:avLst/>
           </a:prstGeom>
         </p:spPr>
       </p:pic>
-      <p:sp>
-        <p:nvSpPr>
-          <p:cNvPr id="6" name="Shape 3"/>
+      <p:pic>
+        <p:nvPicPr>
+          <p:cNvPr id="3" name="Image 1" descr="/home/user/lumine/control-de-gestion/generador/assets/velo.png">    </p:cNvPr>
+          <p:cNvPicPr>
+            <a:picLocks noChangeAspect="1"/>
+          </p:cNvPicPr>
+          <p:nvPr/>
+        </p:nvPicPr>
+        <p:blipFill>
+          <a:blip r:embed="rId2"/>
+          <a:stretch>
+            <a:fillRect/>
+          </a:stretch>
+        </p:blipFill>
+        <p:spPr>
+          <a:xfrm>
+            <a:off x="0" y="4206240"/>
+            <a:ext cx="12191695" cy="2651760"/>
+          </a:xfrm>
+          <a:prstGeom prst="rect">
+            <a:avLst/>
+          </a:prstGeom>
+        </p:spPr>
+      </p:pic>
+      <p:sp>
+        <p:nvSpPr>
+          <p:cNvPr id="4" name="Shape 0"/>
+          <p:cNvSpPr/>
+          <p:nvPr/>
+        </p:nvSpPr>
+        <p:spPr>
+          <a:xfrm>
+            <a:off x="0" y="5669280"/>
+            <a:ext cx="12191695" cy="1188720"/>
+          </a:xfrm>
+          <a:prstGeom prst="rect">
+            <a:avLst/>
+          </a:prstGeom>
+          <a:solidFill>
+            <a:schemeClr val="bg1">
+              <a:alpha val="75000"/>
+            </a:schemeClr>
+          </a:solidFill>
+          <a:ln/>
+        </p:spPr>
+      </p:sp>
+      <p:pic>
+        <p:nvPicPr>
+          <p:cNvPr id="5" name="Image 2" descr="Lumine Motors">    </p:cNvPr>
+          <p:cNvPicPr>
+            <a:picLocks noChangeAspect="1"/>
+          </p:cNvPicPr>
+          <p:nvPr/>
+        </p:nvPicPr>
+        <p:blipFill>
+          <a:blip r:embed="rId3"/>
+          <a:stretch>
+            <a:fillRect/>
+          </a:stretch>
+        </p:blipFill>
+        <p:spPr>
+          <a:xfrm>
+            <a:off x="548640" y="384048"/>
+            <a:ext cx="984563" cy="201168"/>
+          </a:xfrm>
+          <a:prstGeom prst="rect">
+            <a:avLst/>
+          </a:prstGeom>
+        </p:spPr>
+      </p:pic>
+      <p:sp>
+        <p:nvSpPr>
+          <p:cNvPr id="6" name="Text 1"/>
+          <p:cNvSpPr txBox="1"/>
+          <p:nvPr/>
+        </p:nvSpPr>
+        <p:spPr>
+          <a:xfrm>
+            <a:off x="6583680" y="365760"/>
+            <a:ext cx="5059375" cy="237744"/>
+          </a:xfrm>
+          <a:prstGeom prst="rect">
+            <a:avLst/>
+          </a:prstGeom>
+          <a:noFill/>
+          <a:ln/>
+        </p:spPr>
+        <p:txBody>
+          <a:bodyPr wrap="square" lIns="0" tIns="0" rIns="0" bIns="0" rtlCol="0" anchor="ctr"/>
+          <a:lstStyle/>
+          <a:p>
+            <a:pPr algn="r" indent="0" marL="0">
+              <a:buNone/>
+            </a:pPr>
+            <a:r>
+              <a:rPr lang="es-CL" altLang="en-US" sz="900" spc="150" kern="0" dirty="0">
+                <a:solidFill>
+                  <a:schemeClr val="tx2"/>
+                </a:solidFill>
+                <a:latin typeface="IBM Plex Mono" pitchFamily="34" charset="0"/>
+                <a:ea typeface="IBM Plex Mono" pitchFamily="34" charset="-122"/>
+                <a:cs typeface="IBM Plex Mono" pitchFamily="34" charset="-120"/>
+              </a:rPr>
+              <a:t>UNAB · OCTUBRE 2026</a:t>
+            </a:r>
+            <a:endParaRPr lang="es-CL" sz="900" dirty="0"/>
+          </a:p>
+        </p:txBody>
+      </p:sp>
+      <p:sp>
+        <p:nvSpPr>
+          <p:cNvPr id="7" name="Text 2"/>
+          <p:cNvSpPr txBox="1"/>
+          <p:nvPr/>
+        </p:nvSpPr>
+        <p:spPr>
+          <a:xfrm>
+            <a:off x="548640" y="868680"/>
+            <a:ext cx="11094415" cy="274320"/>
+          </a:xfrm>
+          <a:prstGeom prst="rect">
+            <a:avLst/>
+          </a:prstGeom>
+          <a:noFill/>
+          <a:ln/>
+        </p:spPr>
+        <p:txBody>
+          <a:bodyPr wrap="square" lIns="0" tIns="0" rIns="0" bIns="0" rtlCol="0" anchor="ctr"/>
+          <a:lstStyle/>
+          <a:p>
+            <a:pPr algn="ctr" indent="0" marL="0">
+              <a:buNone/>
+            </a:pPr>
+            <a:r>
+              <a:rPr lang="es-CL" altLang="en-US" sz="1000" spc="150" kern="0" dirty="0">
+                <a:solidFill>
+                  <a:schemeClr val="tx2"/>
+                </a:solidFill>
+                <a:latin typeface="IBM Plex Mono" pitchFamily="34" charset="0"/>
+                <a:ea typeface="IBM Plex Mono" pitchFamily="34" charset="-122"/>
+                <a:cs typeface="IBM Plex Mono" pitchFamily="34" charset="-120"/>
+              </a:rPr>
+              <a:t>DESARROLLO DE LA ESTRATEGIA · LUMINE MOTORS CHILE SPA</a:t>
+            </a:r>
+            <a:endParaRPr lang="es-CL" sz="1000" dirty="0"/>
+          </a:p>
+        </p:txBody>
+      </p:sp>
+      <p:sp>
+        <p:nvSpPr>
+          <p:cNvPr id="8" name="Text 0"/>
+          <p:cNvSpPr/>
+          <p:nvPr>
+            <p:ph idx="101" type="title" hasCustomPrompt="1"/>
+          </p:nvPr>
+        </p:nvSpPr>
+        <p:spPr>
+          <a:xfrm>
+            <a:off x="548640" y="1207008"/>
+            <a:ext cx="11094415" cy="914400"/>
+          </a:xfrm>
+          <a:prstGeom prst="rect">
+            <a:avLst/>
+          </a:prstGeom>
+          <a:noFill/>
+          <a:ln/>
+        </p:spPr>
+        <p:txBody>
+          <a:bodyPr wrap="square" lIns="0" tIns="0" rIns="0" bIns="0" rtlCol="0" anchor="t"/>
+          <a:lstStyle/>
+          <a:p>
+            <a:pPr algn="ctr" indent="0" marL="0">
+              <a:lnSpc>
+                <a:spcPct val="86000"/>
+              </a:lnSpc>
+              <a:buNone/>
+            </a:pPr>
+            <a:r>
+              <a:rPr lang="en-US" sz="5000" dirty="0">
+                <a:solidFill>
+                  <a:schemeClr val="tx1"/>
+                </a:solidFill>
+                <a:latin typeface="Archivo SemiExpanded ExtraBold" pitchFamily="34" charset="0"/>
+                <a:ea typeface="Archivo SemiExpanded ExtraBold" pitchFamily="34" charset="-122"/>
+                <a:cs typeface="Archivo SemiExpanded ExtraBold" pitchFamily="34" charset="-120"/>
+              </a:rPr>
+              <a:t>ANÁLISIS </a:t>
+            </a:r>
+            <a:pPr algn="ctr" indent="0" marL="0">
+              <a:lnSpc>
+                <a:spcPct val="86000"/>
+              </a:lnSpc>
+              <a:buNone/>
+            </a:pPr>
+            <a:r>
+              <a:rPr lang="en-US" sz="6200" i="1" dirty="0">
+                <a:solidFill>
+                  <a:schemeClr val="accent1"/>
+                </a:solidFill>
+                <a:latin typeface="Instrument Serif" pitchFamily="34" charset="0"/>
+                <a:ea typeface="Instrument Serif" pitchFamily="34" charset="-122"/>
+                <a:cs typeface="Instrument Serif" pitchFamily="34" charset="-120"/>
+              </a:rPr>
+              <a:t>estratégico.</a:t>
+            </a:r>
+            <a:endParaRPr lang="en-US" sz="5000" dirty="0"/>
+          </a:p>
+        </p:txBody>
+      </p:sp>
+      <p:sp>
+        <p:nvSpPr>
+          <p:cNvPr id="9" name="Shape 4"/>
           <p:cNvSpPr/>
           <p:nvPr/>
         </p:nvSpPr>
@@ -4974,7 +5041,7 @@
       </p:sp>
       <p:sp>
         <p:nvSpPr>
-          <p:cNvPr id="7" name="Text 4"/>
+          <p:cNvPr id="10" name="Text 5"/>
           <p:cNvSpPr txBox="1"/>
           <p:nvPr/>
         </p:nvSpPr>
@@ -5013,7 +5080,7 @@
       </p:sp>
       <p:sp>
         <p:nvSpPr>
-          <p:cNvPr id="8" name="Text 5"/>
+          <p:cNvPr id="11" name="Text 6"/>
           <p:cNvSpPr txBox="1"/>
           <p:nvPr/>
         </p:nvSpPr>
@@ -5052,7 +5119,7 @@
       </p:sp>
       <p:sp>
         <p:nvSpPr>
-          <p:cNvPr id="9" name="Text 6"/>
+          <p:cNvPr id="12" name="Text 7"/>
           <p:cNvSpPr txBox="1"/>
           <p:nvPr/>
         </p:nvSpPr>
@@ -5091,7 +5158,7 @@
       </p:sp>
       <p:sp>
         <p:nvSpPr>
-          <p:cNvPr id="10" name="Text 7"/>
+          <p:cNvPr id="13" name="Text 8"/>
           <p:cNvSpPr txBox="1"/>
           <p:nvPr/>
         </p:nvSpPr>
@@ -5130,7 +5197,7 @@
       </p:sp>
       <p:sp>
         <p:nvSpPr>
-          <p:cNvPr id="11" name="Text 8"/>
+          <p:cNvPr id="14" name="Text 9"/>
           <p:cNvSpPr txBox="1"/>
           <p:nvPr/>
         </p:nvSpPr>
@@ -5169,7 +5236,7 @@
       </p:sp>
       <p:sp>
         <p:nvSpPr>
-          <p:cNvPr id="12" name="Text 9"/>
+          <p:cNvPr id="15" name="Text 10"/>
           <p:cNvSpPr txBox="1"/>
           <p:nvPr/>
         </p:nvSpPr>
@@ -5208,7 +5275,7 @@
       </p:sp>
       <p:sp>
         <p:nvSpPr>
-          <p:cNvPr id="13" name="Text 10"/>
+          <p:cNvPr id="16" name="Text 11"/>
           <p:cNvSpPr txBox="1"/>
           <p:nvPr/>
         </p:nvSpPr>
@@ -5247,7 +5314,7 @@
       </p:sp>
       <p:sp>
         <p:nvSpPr>
-          <p:cNvPr id="14" name="Text 11"/>
+          <p:cNvPr id="17" name="Text 12"/>
           <p:cNvSpPr txBox="1"/>
           <p:nvPr/>
         </p:nvSpPr>

</xml_diff>